<commit_message>
[Mithun.V] Adding Big Endian and Little Endian PPT
</commit_message>
<xml_diff>
--- a/signal_endian.pptx
+++ b/signal_endian.pptx
@@ -241,7 +241,7 @@
           <a:p>
             <a:fld id="{E2B4A87A-13D1-4F51-8C8E-6F570018B2CA}" type="datetimeFigureOut">
               <a:rPr lang="en-US" smtClean="0"/>
-              <a:t>12/24/2025</a:t>
+              <a:t>1/18/2026</a:t>
             </a:fld>
             <a:endParaRPr lang="en-US"/>
           </a:p>
@@ -419,7 +419,7 @@
             <a:fld id="{C1FBD400-178C-4E46-8B1C-98070CB60EB4}" type="datetimeFigureOut">
               <a:rPr lang="en-US" smtClean="0"/>
               <a:pPr/>
-              <a:t>12/24/2025</a:t>
+              <a:t>1/18/2026</a:t>
             </a:fld>
             <a:endParaRPr lang="en-US"/>
           </a:p>
@@ -20377,7 +20377,7 @@
         <p:spPr>
           <a:xfrm>
             <a:off x="4565823" y="5389352"/>
-            <a:ext cx="2720617" cy="369332"/>
+            <a:ext cx="3042345" cy="369332"/>
           </a:xfrm>
           <a:prstGeom prst="rect">
             <a:avLst/>
@@ -20385,7 +20385,7 @@
           <a:noFill/>
         </p:spPr>
         <p:txBody>
-          <a:bodyPr wrap="none" rtlCol="0">
+          <a:bodyPr wrap="square" rtlCol="0">
             <a:spAutoFit/>
           </a:bodyPr>
           <a:lstStyle/>
@@ -24261,6 +24261,14 @@
 </file>
 
 <file path=customXml/item2.xml><?xml version="1.0" encoding="utf-8"?>
+<p:properties xmlns:p="http://schemas.microsoft.com/office/2006/metadata/properties" xmlns:xsi="http://www.w3.org/2001/XMLSchema-instance" xmlns:pc="http://schemas.microsoft.com/office/infopath/2007/PartnerControls">
+  <documentManagement>
+    <MediaServiceKeyPoints xmlns="71af3243-3dd4-4a8d-8c0d-dd76da1f02a5" xsi:nil="true"/>
+  </documentManagement>
+</p:properties>
+</file>
+
+<file path=customXml/item3.xml><?xml version="1.0" encoding="utf-8"?>
 <ct:contentTypeSchema xmlns:ct="http://schemas.microsoft.com/office/2006/metadata/contentType" xmlns:ma="http://schemas.microsoft.com/office/2006/metadata/properties/metaAttributes" ct:_="" ma:_="" ma:contentTypeName="Document" ma:contentTypeID="0x01010079F111ED35F8CC479449609E8A0923A6" ma:contentTypeVersion="11" ma:contentTypeDescription="Create a new document." ma:contentTypeScope="" ma:versionID="96291512c1ee715ab617f4c07df79fc1">
   <xsd:schema xmlns:xsd="http://www.w3.org/2001/XMLSchema" xmlns:xs="http://www.w3.org/2001/XMLSchema" xmlns:p="http://schemas.microsoft.com/office/2006/metadata/properties" xmlns:ns2="71af3243-3dd4-4a8d-8c0d-dd76da1f02a5" xmlns:ns3="16c05727-aa75-4e4a-9b5f-8a80a1165891" targetNamespace="http://schemas.microsoft.com/office/2006/metadata/properties" ma:root="true" ma:fieldsID="8256c27c40ca5c40ce1cf6c44f0205df" ns2:_="" ns3:_="">
     <xsd:import namespace="71af3243-3dd4-4a8d-8c0d-dd76da1f02a5"/>
@@ -24471,14 +24479,6 @@
 </ct:contentTypeSchema>
 </file>
 
-<file path=customXml/item3.xml><?xml version="1.0" encoding="utf-8"?>
-<p:properties xmlns:p="http://schemas.microsoft.com/office/2006/metadata/properties" xmlns:xsi="http://www.w3.org/2001/XMLSchema-instance" xmlns:pc="http://schemas.microsoft.com/office/infopath/2007/PartnerControls">
-  <documentManagement>
-    <MediaServiceKeyPoints xmlns="71af3243-3dd4-4a8d-8c0d-dd76da1f02a5" xsi:nil="true"/>
-  </documentManagement>
-</p:properties>
-</file>
-
 <file path=customXml/itemProps1.xml><?xml version="1.0" encoding="utf-8"?>
 <ds:datastoreItem xmlns:ds="http://schemas.openxmlformats.org/officeDocument/2006/customXml" ds:itemID="{F7FD1FC1-9AE0-4D49-BC7A-F1CBE0EA4CD8}">
   <ds:schemaRefs>
@@ -24488,6 +24488,16 @@
 </file>
 
 <file path=customXml/itemProps2.xml><?xml version="1.0" encoding="utf-8"?>
+<ds:datastoreItem xmlns:ds="http://schemas.openxmlformats.org/officeDocument/2006/customXml" ds:itemID="{2DAF5101-E7B6-4532-BC0B-676AAA5858F1}">
+  <ds:schemaRefs>
+    <ds:schemaRef ds:uri="http://schemas.microsoft.com/office/2006/metadata/properties"/>
+    <ds:schemaRef ds:uri="http://schemas.microsoft.com/office/infopath/2007/PartnerControls"/>
+    <ds:schemaRef ds:uri="71af3243-3dd4-4a8d-8c0d-dd76da1f02a5"/>
+  </ds:schemaRefs>
+</ds:datastoreItem>
+</file>
+
+<file path=customXml/itemProps3.xml><?xml version="1.0" encoding="utf-8"?>
 <ds:datastoreItem xmlns:ds="http://schemas.openxmlformats.org/officeDocument/2006/customXml" ds:itemID="{1AB5A952-DE37-4D36-8C1C-D7CF99F14915}">
   <ds:schemaRefs>
     <ds:schemaRef ds:uri="http://schemas.microsoft.com/office/2006/metadata/contentType"/>
@@ -24504,14 +24514,4 @@
     <ds:schemaRef ds:uri="http://schemas.microsoft.com/internal/obd"/>
   </ds:schemaRefs>
 </ds:datastoreItem>
-</file>
-
-<file path=customXml/itemProps3.xml><?xml version="1.0" encoding="utf-8"?>
-<ds:datastoreItem xmlns:ds="http://schemas.openxmlformats.org/officeDocument/2006/customXml" ds:itemID="{2DAF5101-E7B6-4532-BC0B-676AAA5858F1}">
-  <ds:schemaRefs>
-    <ds:schemaRef ds:uri="http://schemas.microsoft.com/office/2006/metadata/properties"/>
-    <ds:schemaRef ds:uri="http://schemas.microsoft.com/office/infopath/2007/PartnerControls"/>
-    <ds:schemaRef ds:uri="71af3243-3dd4-4a8d-8c0d-dd76da1f02a5"/>
-  </ds:schemaRefs>
-</ds:datastoreItem>
 </file>
</xml_diff>